<commit_message>
Slider- Backend slider create page design
</commit_message>
<xml_diff>
--- a/.lessons/54 Slider Features/2 Slider- Backend slider create page design/1.pptx
+++ b/.lessons/54 Slider Features/2 Slider- Backend slider create page design/1.pptx
@@ -5,9 +5,19 @@
     <p:sldMasterId id="2147483648" r:id="rId1"/>
   </p:sldMasterIdLst>
   <p:sldIdLst>
-    <p:sldId id="413" r:id="rId2"/>
-    <p:sldId id="414" r:id="rId3"/>
-    <p:sldId id="400" r:id="rId4"/>
+    <p:sldId id="416" r:id="rId2"/>
+    <p:sldId id="413" r:id="rId3"/>
+    <p:sldId id="415" r:id="rId4"/>
+    <p:sldId id="414" r:id="rId5"/>
+    <p:sldId id="417" r:id="rId6"/>
+    <p:sldId id="418" r:id="rId7"/>
+    <p:sldId id="421" r:id="rId8"/>
+    <p:sldId id="422" r:id="rId9"/>
+    <p:sldId id="423" r:id="rId10"/>
+    <p:sldId id="424" r:id="rId11"/>
+    <p:sldId id="419" r:id="rId12"/>
+    <p:sldId id="420" r:id="rId13"/>
+    <p:sldId id="400" r:id="rId14"/>
   </p:sldIdLst>
   <p:sldSz cx="12192000" cy="6858000"/>
   <p:notesSz cx="6858000" cy="9144000"/>
@@ -261,7 +271,7 @@
           <a:p>
             <a:fld id="{3E102D2E-813C-461C-9963-687A650C48C0}" type="datetimeFigureOut">
               <a:rPr lang="en-US" smtClean="0"/>
-              <a:t>6/26/2025</a:t>
+              <a:t>8/5/2025</a:t>
             </a:fld>
             <a:endParaRPr lang="en-US"/>
           </a:p>
@@ -459,7 +469,7 @@
           <a:p>
             <a:fld id="{3E102D2E-813C-461C-9963-687A650C48C0}" type="datetimeFigureOut">
               <a:rPr lang="en-US" smtClean="0"/>
-              <a:t>6/26/2025</a:t>
+              <a:t>8/5/2025</a:t>
             </a:fld>
             <a:endParaRPr lang="en-US"/>
           </a:p>
@@ -667,7 +677,7 @@
           <a:p>
             <a:fld id="{3E102D2E-813C-461C-9963-687A650C48C0}" type="datetimeFigureOut">
               <a:rPr lang="en-US" smtClean="0"/>
-              <a:t>6/26/2025</a:t>
+              <a:t>8/5/2025</a:t>
             </a:fld>
             <a:endParaRPr lang="en-US"/>
           </a:p>
@@ -865,7 +875,7 @@
           <a:p>
             <a:fld id="{3E102D2E-813C-461C-9963-687A650C48C0}" type="datetimeFigureOut">
               <a:rPr lang="en-US" smtClean="0"/>
-              <a:t>6/26/2025</a:t>
+              <a:t>8/5/2025</a:t>
             </a:fld>
             <a:endParaRPr lang="en-US"/>
           </a:p>
@@ -1140,7 +1150,7 @@
           <a:p>
             <a:fld id="{3E102D2E-813C-461C-9963-687A650C48C0}" type="datetimeFigureOut">
               <a:rPr lang="en-US" smtClean="0"/>
-              <a:t>6/26/2025</a:t>
+              <a:t>8/5/2025</a:t>
             </a:fld>
             <a:endParaRPr lang="en-US"/>
           </a:p>
@@ -1405,7 +1415,7 @@
           <a:p>
             <a:fld id="{3E102D2E-813C-461C-9963-687A650C48C0}" type="datetimeFigureOut">
               <a:rPr lang="en-US" smtClean="0"/>
-              <a:t>6/26/2025</a:t>
+              <a:t>8/5/2025</a:t>
             </a:fld>
             <a:endParaRPr lang="en-US"/>
           </a:p>
@@ -1817,7 +1827,7 @@
           <a:p>
             <a:fld id="{3E102D2E-813C-461C-9963-687A650C48C0}" type="datetimeFigureOut">
               <a:rPr lang="en-US" smtClean="0"/>
-              <a:t>6/26/2025</a:t>
+              <a:t>8/5/2025</a:t>
             </a:fld>
             <a:endParaRPr lang="en-US"/>
           </a:p>
@@ -1958,7 +1968,7 @@
           <a:p>
             <a:fld id="{3E102D2E-813C-461C-9963-687A650C48C0}" type="datetimeFigureOut">
               <a:rPr lang="en-US" smtClean="0"/>
-              <a:t>6/26/2025</a:t>
+              <a:t>8/5/2025</a:t>
             </a:fld>
             <a:endParaRPr lang="en-US"/>
           </a:p>
@@ -2071,7 +2081,7 @@
           <a:p>
             <a:fld id="{3E102D2E-813C-461C-9963-687A650C48C0}" type="datetimeFigureOut">
               <a:rPr lang="en-US" smtClean="0"/>
-              <a:t>6/26/2025</a:t>
+              <a:t>8/5/2025</a:t>
             </a:fld>
             <a:endParaRPr lang="en-US"/>
           </a:p>
@@ -2382,7 +2392,7 @@
           <a:p>
             <a:fld id="{3E102D2E-813C-461C-9963-687A650C48C0}" type="datetimeFigureOut">
               <a:rPr lang="en-US" smtClean="0"/>
-              <a:t>6/26/2025</a:t>
+              <a:t>8/5/2025</a:t>
             </a:fld>
             <a:endParaRPr lang="en-US"/>
           </a:p>
@@ -2670,7 +2680,7 @@
           <a:p>
             <a:fld id="{3E102D2E-813C-461C-9963-687A650C48C0}" type="datetimeFigureOut">
               <a:rPr lang="en-US" smtClean="0"/>
-              <a:t>6/26/2025</a:t>
+              <a:t>8/5/2025</a:t>
             </a:fld>
             <a:endParaRPr lang="en-US"/>
           </a:p>
@@ -2911,7 +2921,7 @@
           <a:p>
             <a:fld id="{3E102D2E-813C-461C-9963-687A650C48C0}" type="datetimeFigureOut">
               <a:rPr lang="en-US" smtClean="0"/>
-              <a:t>6/26/2025</a:t>
+              <a:t>8/5/2025</a:t>
             </a:fld>
             <a:endParaRPr lang="en-US"/>
           </a:p>
@@ -3319,6 +3329,550 @@
         <p:cNvPr id="1" name="">
           <a:extLst>
             <a:ext uri="{FF2B5EF4-FFF2-40B4-BE49-F238E27FC236}">
+              <a16:creationId xmlns:a16="http://schemas.microsoft.com/office/drawing/2014/main" id="{84724583-EC4A-E3E4-0D76-28AC848C7AB2}"/>
+            </a:ext>
+          </a:extLst>
+        </p:cNvPr>
+        <p:cNvGrpSpPr/>
+        <p:nvPr/>
+      </p:nvGrpSpPr>
+      <p:grpSpPr>
+        <a:xfrm>
+          <a:off x="0" y="0"/>
+          <a:ext cx="0" cy="0"/>
+          <a:chOff x="0" y="0"/>
+          <a:chExt cx="0" cy="0"/>
+        </a:xfrm>
+      </p:grpSpPr>
+      <p:sp>
+        <p:nvSpPr>
+          <p:cNvPr id="3" name="TextBox 2">
+            <a:extLst>
+              <a:ext uri="{FF2B5EF4-FFF2-40B4-BE49-F238E27FC236}">
+                <a16:creationId xmlns:a16="http://schemas.microsoft.com/office/drawing/2014/main" id="{F4F7EF0E-9039-B1ED-153E-592926E40BBB}"/>
+              </a:ext>
+            </a:extLst>
+          </p:cNvPr>
+          <p:cNvSpPr txBox="1"/>
+          <p:nvPr/>
+        </p:nvSpPr>
+        <p:spPr>
+          <a:xfrm>
+            <a:off x="217714" y="255046"/>
+            <a:ext cx="11756571" cy="655436"/>
+          </a:xfrm>
+          <a:prstGeom prst="rect">
+            <a:avLst/>
+          </a:prstGeom>
+          <a:noFill/>
+        </p:spPr>
+        <p:txBody>
+          <a:bodyPr wrap="square">
+            <a:spAutoFit/>
+          </a:bodyPr>
+          <a:lstStyle/>
+          <a:p>
+            <a:pPr>
+              <a:lnSpc>
+                <a:spcPct val="150000"/>
+              </a:lnSpc>
+              <a:buNone/>
+            </a:pPr>
+            <a:r>
+              <a:rPr lang="az-Latn-AZ" altLang="en-US" sz="1300">
+                <a:latin typeface="Arial" panose="020B0604020202020204" pitchFamily="34" charset="0"/>
+              </a:rPr>
+              <a:t>Slider əlavə etmək üçün istifadə edilən `</a:t>
+            </a:r>
+            <a:r>
+              <a:rPr lang="en-US" altLang="en-US" sz="1300" b="1">
+                <a:latin typeface="Arial" panose="020B0604020202020204" pitchFamily="34" charset="0"/>
+              </a:rPr>
+              <a:t>resources\views\admin\slider\</a:t>
+            </a:r>
+            <a:r>
+              <a:rPr lang="en-US" altLang="en-US" sz="1300" b="1" u="sng">
+                <a:latin typeface="Arial" panose="020B0604020202020204" pitchFamily="34" charset="0"/>
+              </a:rPr>
+              <a:t>create.blade.php</a:t>
+            </a:r>
+            <a:r>
+              <a:rPr lang="az-Latn-AZ" altLang="en-US" sz="1300">
+                <a:latin typeface="Arial" panose="020B0604020202020204" pitchFamily="34" charset="0"/>
+              </a:rPr>
+              <a:t>` səhifəsinə getmək üçün, </a:t>
+            </a:r>
+            <a:r>
+              <a:rPr lang="en-US" altLang="en-US" sz="1300" b="1">
+                <a:latin typeface="Arial" panose="020B0604020202020204" pitchFamily="34" charset="0"/>
+              </a:rPr>
+              <a:t>&lt;a&gt;</a:t>
+            </a:r>
+            <a:r>
+              <a:rPr lang="en-US" altLang="en-US" sz="1300">
+                <a:latin typeface="Arial" panose="020B0604020202020204" pitchFamily="34" charset="0"/>
+              </a:rPr>
+              <a:t> </a:t>
+            </a:r>
+            <a:r>
+              <a:rPr lang="az-Latn-AZ" altLang="en-US" sz="1300">
+                <a:latin typeface="Arial" panose="020B0604020202020204" pitchFamily="34" charset="0"/>
+              </a:rPr>
+              <a:t>elementinə, bizi həmin səhifəyə yönləndirəcək </a:t>
+            </a:r>
+            <a:r>
+              <a:rPr lang="az-Latn-AZ" altLang="en-US" sz="1300" b="1">
+                <a:latin typeface="Arial" panose="020B0604020202020204" pitchFamily="34" charset="0"/>
+              </a:rPr>
+              <a:t>route</a:t>
+            </a:r>
+            <a:r>
+              <a:rPr lang="az-Latn-AZ" altLang="en-US" sz="1300">
+                <a:latin typeface="Arial" panose="020B0604020202020204" pitchFamily="34" charset="0"/>
+              </a:rPr>
+              <a:t> -u əlavə edirik.</a:t>
+            </a:r>
+            <a:endParaRPr kumimoji="0" lang="en-US" altLang="en-US" sz="1300" b="0" i="0" u="none" strike="noStrike" cap="none" normalizeH="0" baseline="0">
+              <a:ln>
+                <a:noFill/>
+              </a:ln>
+              <a:solidFill>
+                <a:schemeClr val="tx1"/>
+              </a:solidFill>
+              <a:effectLst/>
+              <a:latin typeface="Arial" panose="020B0604020202020204" pitchFamily="34" charset="0"/>
+            </a:endParaRPr>
+          </a:p>
+        </p:txBody>
+      </p:sp>
+      <p:pic>
+        <p:nvPicPr>
+          <p:cNvPr id="4" name="Picture 3">
+            <a:extLst>
+              <a:ext uri="{FF2B5EF4-FFF2-40B4-BE49-F238E27FC236}">
+                <a16:creationId xmlns:a16="http://schemas.microsoft.com/office/drawing/2014/main" id="{F8032E95-7CBD-C190-2ADD-0B2878D6C1B0}"/>
+              </a:ext>
+            </a:extLst>
+          </p:cNvPr>
+          <p:cNvPicPr>
+            <a:picLocks noChangeAspect="1"/>
+          </p:cNvPicPr>
+          <p:nvPr/>
+        </p:nvPicPr>
+        <p:blipFill>
+          <a:blip r:embed="rId2"/>
+          <a:stretch>
+            <a:fillRect/>
+          </a:stretch>
+        </p:blipFill>
+        <p:spPr>
+          <a:xfrm>
+            <a:off x="2946400" y="1121720"/>
+            <a:ext cx="9245600" cy="5736279"/>
+          </a:xfrm>
+          <a:prstGeom prst="rect">
+            <a:avLst/>
+          </a:prstGeom>
+        </p:spPr>
+      </p:pic>
+    </p:spTree>
+    <p:extLst>
+      <p:ext uri="{BB962C8B-B14F-4D97-AF65-F5344CB8AC3E}">
+        <p14:creationId xmlns:p14="http://schemas.microsoft.com/office/powerpoint/2010/main" val="1357058976"/>
+      </p:ext>
+    </p:extLst>
+  </p:cSld>
+  <p:clrMapOvr>
+    <a:masterClrMapping/>
+  </p:clrMapOvr>
+</p:sld>
+</file>
+
+<file path=ppt/slides/slide10.xml><?xml version="1.0" encoding="utf-8"?>
+<p:sld xmlns:a="http://schemas.openxmlformats.org/drawingml/2006/main" xmlns:r="http://schemas.openxmlformats.org/officeDocument/2006/relationships" xmlns:p="http://schemas.openxmlformats.org/presentationml/2006/main">
+  <p:cSld>
+    <p:spTree>
+      <p:nvGrpSpPr>
+        <p:cNvPr id="1" name="">
+          <a:extLst>
+            <a:ext uri="{FF2B5EF4-FFF2-40B4-BE49-F238E27FC236}">
+              <a16:creationId xmlns:a16="http://schemas.microsoft.com/office/drawing/2014/main" id="{5EE54F2F-4720-99B7-B8E8-7851C19B31F4}"/>
+            </a:ext>
+          </a:extLst>
+        </p:cNvPr>
+        <p:cNvGrpSpPr/>
+        <p:nvPr/>
+      </p:nvGrpSpPr>
+      <p:grpSpPr>
+        <a:xfrm>
+          <a:off x="0" y="0"/>
+          <a:ext cx="0" cy="0"/>
+          <a:chOff x="0" y="0"/>
+          <a:chExt cx="0" cy="0"/>
+        </a:xfrm>
+      </p:grpSpPr>
+      <p:sp>
+        <p:nvSpPr>
+          <p:cNvPr id="3" name="TextBox 2">
+            <a:extLst>
+              <a:ext uri="{FF2B5EF4-FFF2-40B4-BE49-F238E27FC236}">
+                <a16:creationId xmlns:a16="http://schemas.microsoft.com/office/drawing/2014/main" id="{48C14039-6598-C0AB-A297-265C510A83B2}"/>
+              </a:ext>
+            </a:extLst>
+          </p:cNvPr>
+          <p:cNvSpPr txBox="1"/>
+          <p:nvPr/>
+        </p:nvSpPr>
+        <p:spPr>
+          <a:xfrm>
+            <a:off x="217714" y="98027"/>
+            <a:ext cx="11756571" cy="355354"/>
+          </a:xfrm>
+          <a:prstGeom prst="rect">
+            <a:avLst/>
+          </a:prstGeom>
+          <a:noFill/>
+        </p:spPr>
+        <p:txBody>
+          <a:bodyPr wrap="square">
+            <a:spAutoFit/>
+          </a:bodyPr>
+          <a:lstStyle/>
+          <a:p>
+            <a:pPr>
+              <a:lnSpc>
+                <a:spcPct val="150000"/>
+              </a:lnSpc>
+              <a:buNone/>
+            </a:pPr>
+            <a:r>
+              <a:rPr lang="az-Latn-AZ" altLang="en-US" sz="1300">
+                <a:latin typeface="Arial" panose="020B0604020202020204" pitchFamily="34" charset="0"/>
+              </a:rPr>
+              <a:t>Nəticə.</a:t>
+            </a:r>
+            <a:endParaRPr kumimoji="0" lang="en-US" altLang="en-US" sz="1300" b="0" i="0" u="none" strike="noStrike" cap="none" normalizeH="0" baseline="0">
+              <a:ln>
+                <a:noFill/>
+              </a:ln>
+              <a:solidFill>
+                <a:schemeClr val="tx1"/>
+              </a:solidFill>
+              <a:effectLst/>
+              <a:latin typeface="Arial" panose="020B0604020202020204" pitchFamily="34" charset="0"/>
+            </a:endParaRPr>
+          </a:p>
+        </p:txBody>
+      </p:sp>
+      <p:pic>
+        <p:nvPicPr>
+          <p:cNvPr id="4" name="Picture 3">
+            <a:extLst>
+              <a:ext uri="{FF2B5EF4-FFF2-40B4-BE49-F238E27FC236}">
+                <a16:creationId xmlns:a16="http://schemas.microsoft.com/office/drawing/2014/main" id="{84DBF1E0-195B-86EE-8BC0-D6D70589E1C0}"/>
+              </a:ext>
+            </a:extLst>
+          </p:cNvPr>
+          <p:cNvPicPr>
+            <a:picLocks noChangeAspect="1"/>
+          </p:cNvPicPr>
+          <p:nvPr/>
+        </p:nvPicPr>
+        <p:blipFill>
+          <a:blip r:embed="rId2"/>
+          <a:stretch>
+            <a:fillRect/>
+          </a:stretch>
+        </p:blipFill>
+        <p:spPr>
+          <a:xfrm>
+            <a:off x="0" y="561871"/>
+            <a:ext cx="12192000" cy="6296129"/>
+          </a:xfrm>
+          <a:prstGeom prst="rect">
+            <a:avLst/>
+          </a:prstGeom>
+        </p:spPr>
+      </p:pic>
+    </p:spTree>
+    <p:extLst>
+      <p:ext uri="{BB962C8B-B14F-4D97-AF65-F5344CB8AC3E}">
+        <p14:creationId xmlns:p14="http://schemas.microsoft.com/office/powerpoint/2010/main" val="3240147667"/>
+      </p:ext>
+    </p:extLst>
+  </p:cSld>
+  <p:clrMapOvr>
+    <a:masterClrMapping/>
+  </p:clrMapOvr>
+</p:sld>
+</file>
+
+<file path=ppt/slides/slide11.xml><?xml version="1.0" encoding="utf-8"?>
+<p:sld xmlns:a="http://schemas.openxmlformats.org/drawingml/2006/main" xmlns:r="http://schemas.openxmlformats.org/officeDocument/2006/relationships" xmlns:p="http://schemas.openxmlformats.org/presentationml/2006/main">
+  <p:cSld>
+    <p:spTree>
+      <p:nvGrpSpPr>
+        <p:cNvPr id="1" name="">
+          <a:extLst>
+            <a:ext uri="{FF2B5EF4-FFF2-40B4-BE49-F238E27FC236}">
+              <a16:creationId xmlns:a16="http://schemas.microsoft.com/office/drawing/2014/main" id="{6375ECBB-BD31-B5B0-1B04-6C5DB1FBB367}"/>
+            </a:ext>
+          </a:extLst>
+        </p:cNvPr>
+        <p:cNvGrpSpPr/>
+        <p:nvPr/>
+      </p:nvGrpSpPr>
+      <p:grpSpPr>
+        <a:xfrm>
+          <a:off x="0" y="0"/>
+          <a:ext cx="0" cy="0"/>
+          <a:chOff x="0" y="0"/>
+          <a:chExt cx="0" cy="0"/>
+        </a:xfrm>
+      </p:grpSpPr>
+      <p:sp>
+        <p:nvSpPr>
+          <p:cNvPr id="3" name="TextBox 2">
+            <a:extLst>
+              <a:ext uri="{FF2B5EF4-FFF2-40B4-BE49-F238E27FC236}">
+                <a16:creationId xmlns:a16="http://schemas.microsoft.com/office/drawing/2014/main" id="{29C83E70-E79C-23BF-F164-B4755B87EC84}"/>
+              </a:ext>
+            </a:extLst>
+          </p:cNvPr>
+          <p:cNvSpPr txBox="1"/>
+          <p:nvPr/>
+        </p:nvSpPr>
+        <p:spPr>
+          <a:xfrm>
+            <a:off x="217714" y="255046"/>
+            <a:ext cx="11756571" cy="355354"/>
+          </a:xfrm>
+          <a:prstGeom prst="rect">
+            <a:avLst/>
+          </a:prstGeom>
+          <a:noFill/>
+        </p:spPr>
+        <p:txBody>
+          <a:bodyPr wrap="square">
+            <a:spAutoFit/>
+          </a:bodyPr>
+          <a:lstStyle/>
+          <a:p>
+            <a:pPr>
+              <a:lnSpc>
+                <a:spcPct val="150000"/>
+              </a:lnSpc>
+              <a:buNone/>
+            </a:pPr>
+            <a:r>
+              <a:rPr kumimoji="0" lang="en-US" altLang="en-US" sz="1300" b="0" i="0" u="none" strike="noStrike" cap="none" normalizeH="0" baseline="0">
+                <a:ln>
+                  <a:noFill/>
+                </a:ln>
+                <a:solidFill>
+                  <a:schemeClr val="tx1"/>
+                </a:solidFill>
+                <a:effectLst/>
+                <a:latin typeface="Arial" panose="020B0604020202020204" pitchFamily="34" charset="0"/>
+              </a:rPr>
+              <a:t>.</a:t>
+            </a:r>
+          </a:p>
+        </p:txBody>
+      </p:sp>
+    </p:spTree>
+    <p:extLst>
+      <p:ext uri="{BB962C8B-B14F-4D97-AF65-F5344CB8AC3E}">
+        <p14:creationId xmlns:p14="http://schemas.microsoft.com/office/powerpoint/2010/main" val="3562041772"/>
+      </p:ext>
+    </p:extLst>
+  </p:cSld>
+  <p:clrMapOvr>
+    <a:masterClrMapping/>
+  </p:clrMapOvr>
+</p:sld>
+</file>
+
+<file path=ppt/slides/slide12.xml><?xml version="1.0" encoding="utf-8"?>
+<p:sld xmlns:a="http://schemas.openxmlformats.org/drawingml/2006/main" xmlns:r="http://schemas.openxmlformats.org/officeDocument/2006/relationships" xmlns:p="http://schemas.openxmlformats.org/presentationml/2006/main">
+  <p:cSld>
+    <p:spTree>
+      <p:nvGrpSpPr>
+        <p:cNvPr id="1" name="">
+          <a:extLst>
+            <a:ext uri="{FF2B5EF4-FFF2-40B4-BE49-F238E27FC236}">
+              <a16:creationId xmlns:a16="http://schemas.microsoft.com/office/drawing/2014/main" id="{4DF8214A-43F8-27BA-B6AB-04430612E5D5}"/>
+            </a:ext>
+          </a:extLst>
+        </p:cNvPr>
+        <p:cNvGrpSpPr/>
+        <p:nvPr/>
+      </p:nvGrpSpPr>
+      <p:grpSpPr>
+        <a:xfrm>
+          <a:off x="0" y="0"/>
+          <a:ext cx="0" cy="0"/>
+          <a:chOff x="0" y="0"/>
+          <a:chExt cx="0" cy="0"/>
+        </a:xfrm>
+      </p:grpSpPr>
+      <p:sp>
+        <p:nvSpPr>
+          <p:cNvPr id="3" name="TextBox 2">
+            <a:extLst>
+              <a:ext uri="{FF2B5EF4-FFF2-40B4-BE49-F238E27FC236}">
+                <a16:creationId xmlns:a16="http://schemas.microsoft.com/office/drawing/2014/main" id="{A6CA647C-DE0C-F04B-16B5-64903D85D09B}"/>
+              </a:ext>
+            </a:extLst>
+          </p:cNvPr>
+          <p:cNvSpPr txBox="1"/>
+          <p:nvPr/>
+        </p:nvSpPr>
+        <p:spPr>
+          <a:xfrm>
+            <a:off x="217714" y="255046"/>
+            <a:ext cx="11756571" cy="355354"/>
+          </a:xfrm>
+          <a:prstGeom prst="rect">
+            <a:avLst/>
+          </a:prstGeom>
+          <a:noFill/>
+        </p:spPr>
+        <p:txBody>
+          <a:bodyPr wrap="square">
+            <a:spAutoFit/>
+          </a:bodyPr>
+          <a:lstStyle/>
+          <a:p>
+            <a:pPr>
+              <a:lnSpc>
+                <a:spcPct val="150000"/>
+              </a:lnSpc>
+              <a:buNone/>
+            </a:pPr>
+            <a:r>
+              <a:rPr kumimoji="0" lang="en-US" altLang="en-US" sz="1300" b="0" i="0" u="none" strike="noStrike" cap="none" normalizeH="0" baseline="0">
+                <a:ln>
+                  <a:noFill/>
+                </a:ln>
+                <a:solidFill>
+                  <a:schemeClr val="tx1"/>
+                </a:solidFill>
+                <a:effectLst/>
+                <a:latin typeface="Arial" panose="020B0604020202020204" pitchFamily="34" charset="0"/>
+              </a:rPr>
+              <a:t>.</a:t>
+            </a:r>
+          </a:p>
+        </p:txBody>
+      </p:sp>
+    </p:spTree>
+    <p:extLst>
+      <p:ext uri="{BB962C8B-B14F-4D97-AF65-F5344CB8AC3E}">
+        <p14:creationId xmlns:p14="http://schemas.microsoft.com/office/powerpoint/2010/main" val="1420293800"/>
+      </p:ext>
+    </p:extLst>
+  </p:cSld>
+  <p:clrMapOvr>
+    <a:masterClrMapping/>
+  </p:clrMapOvr>
+</p:sld>
+</file>
+
+<file path=ppt/slides/slide13.xml><?xml version="1.0" encoding="utf-8"?>
+<p:sld xmlns:a="http://schemas.openxmlformats.org/drawingml/2006/main" xmlns:r="http://schemas.openxmlformats.org/officeDocument/2006/relationships" xmlns:p="http://schemas.openxmlformats.org/presentationml/2006/main">
+  <p:cSld>
+    <p:spTree>
+      <p:nvGrpSpPr>
+        <p:cNvPr id="1" name="">
+          <a:extLst>
+            <a:ext uri="{FF2B5EF4-FFF2-40B4-BE49-F238E27FC236}">
+              <a16:creationId xmlns:a16="http://schemas.microsoft.com/office/drawing/2014/main" id="{ECE25D7D-A080-F22B-7E8D-36EC827289A1}"/>
+            </a:ext>
+          </a:extLst>
+        </p:cNvPr>
+        <p:cNvGrpSpPr/>
+        <p:nvPr/>
+      </p:nvGrpSpPr>
+      <p:grpSpPr>
+        <a:xfrm>
+          <a:off x="0" y="0"/>
+          <a:ext cx="0" cy="0"/>
+          <a:chOff x="0" y="0"/>
+          <a:chExt cx="0" cy="0"/>
+        </a:xfrm>
+      </p:grpSpPr>
+      <p:sp>
+        <p:nvSpPr>
+          <p:cNvPr id="3" name="TextBox 2">
+            <a:extLst>
+              <a:ext uri="{FF2B5EF4-FFF2-40B4-BE49-F238E27FC236}">
+                <a16:creationId xmlns:a16="http://schemas.microsoft.com/office/drawing/2014/main" id="{E33F16A3-A6E8-401E-847B-09570DC6E4CB}"/>
+              </a:ext>
+            </a:extLst>
+          </p:cNvPr>
+          <p:cNvSpPr txBox="1"/>
+          <p:nvPr/>
+        </p:nvSpPr>
+        <p:spPr>
+          <a:xfrm>
+            <a:off x="217714" y="255046"/>
+            <a:ext cx="11756571" cy="355354"/>
+          </a:xfrm>
+          <a:prstGeom prst="rect">
+            <a:avLst/>
+          </a:prstGeom>
+          <a:noFill/>
+        </p:spPr>
+        <p:txBody>
+          <a:bodyPr wrap="square">
+            <a:spAutoFit/>
+          </a:bodyPr>
+          <a:lstStyle/>
+          <a:p>
+            <a:pPr>
+              <a:lnSpc>
+                <a:spcPct val="150000"/>
+              </a:lnSpc>
+              <a:buNone/>
+            </a:pPr>
+            <a:r>
+              <a:rPr kumimoji="0" lang="en-US" altLang="en-US" sz="1300" b="0" i="0" u="none" strike="noStrike" cap="none" normalizeH="0" baseline="0">
+                <a:ln>
+                  <a:noFill/>
+                </a:ln>
+                <a:solidFill>
+                  <a:schemeClr val="tx1"/>
+                </a:solidFill>
+                <a:effectLst/>
+                <a:latin typeface="Arial" panose="020B0604020202020204" pitchFamily="34" charset="0"/>
+              </a:rPr>
+              <a:t>.</a:t>
+            </a:r>
+          </a:p>
+        </p:txBody>
+      </p:sp>
+    </p:spTree>
+    <p:extLst>
+      <p:ext uri="{BB962C8B-B14F-4D97-AF65-F5344CB8AC3E}">
+        <p14:creationId xmlns:p14="http://schemas.microsoft.com/office/powerpoint/2010/main" val="3095838342"/>
+      </p:ext>
+    </p:extLst>
+  </p:cSld>
+  <p:clrMapOvr>
+    <a:masterClrMapping/>
+  </p:clrMapOvr>
+</p:sld>
+</file>
+
+<file path=ppt/slides/slide2.xml><?xml version="1.0" encoding="utf-8"?>
+<p:sld xmlns:a="http://schemas.openxmlformats.org/drawingml/2006/main" xmlns:r="http://schemas.openxmlformats.org/officeDocument/2006/relationships" xmlns:p="http://schemas.openxmlformats.org/presentationml/2006/main">
+  <p:cSld>
+    <p:spTree>
+      <p:nvGrpSpPr>
+        <p:cNvPr id="1" name="">
+          <a:extLst>
+            <a:ext uri="{FF2B5EF4-FFF2-40B4-BE49-F238E27FC236}">
               <a16:creationId xmlns:a16="http://schemas.microsoft.com/office/drawing/2014/main" id="{6A435CBA-29A4-BFD2-CEA7-3290D85ED9F8}"/>
             </a:ext>
           </a:extLst>
@@ -3384,6 +3938,36 @@
           </a:p>
         </p:txBody>
       </p:sp>
+      <p:pic>
+        <p:nvPicPr>
+          <p:cNvPr id="4" name="Picture 3">
+            <a:extLst>
+              <a:ext uri="{FF2B5EF4-FFF2-40B4-BE49-F238E27FC236}">
+                <a16:creationId xmlns:a16="http://schemas.microsoft.com/office/drawing/2014/main" id="{64FEB530-C242-CB39-C655-BF8980487D21}"/>
+              </a:ext>
+            </a:extLst>
+          </p:cNvPr>
+          <p:cNvPicPr>
+            <a:picLocks noChangeAspect="1"/>
+          </p:cNvPicPr>
+          <p:nvPr/>
+        </p:nvPicPr>
+        <p:blipFill>
+          <a:blip r:embed="rId2"/>
+          <a:stretch>
+            <a:fillRect/>
+          </a:stretch>
+        </p:blipFill>
+        <p:spPr>
+          <a:xfrm>
+            <a:off x="8488680" y="0"/>
+            <a:ext cx="3703320" cy="6858000"/>
+          </a:xfrm>
+          <a:prstGeom prst="rect">
+            <a:avLst/>
+          </a:prstGeom>
+        </p:spPr>
+      </p:pic>
     </p:spTree>
     <p:extLst>
       <p:ext uri="{BB962C8B-B14F-4D97-AF65-F5344CB8AC3E}">
@@ -3397,7 +3981,137 @@
 </p:sld>
 </file>
 
-<file path=ppt/slides/slide2.xml><?xml version="1.0" encoding="utf-8"?>
+<file path=ppt/slides/slide3.xml><?xml version="1.0" encoding="utf-8"?>
+<p:sld xmlns:a="http://schemas.openxmlformats.org/drawingml/2006/main" xmlns:r="http://schemas.openxmlformats.org/officeDocument/2006/relationships" xmlns:p="http://schemas.openxmlformats.org/presentationml/2006/main">
+  <p:cSld>
+    <p:spTree>
+      <p:nvGrpSpPr>
+        <p:cNvPr id="1" name="">
+          <a:extLst>
+            <a:ext uri="{FF2B5EF4-FFF2-40B4-BE49-F238E27FC236}">
+              <a16:creationId xmlns:a16="http://schemas.microsoft.com/office/drawing/2014/main" id="{CB69A569-57B6-28E1-DFA5-7BA80BE92F16}"/>
+            </a:ext>
+          </a:extLst>
+        </p:cNvPr>
+        <p:cNvGrpSpPr/>
+        <p:nvPr/>
+      </p:nvGrpSpPr>
+      <p:grpSpPr>
+        <a:xfrm>
+          <a:off x="0" y="0"/>
+          <a:ext cx="0" cy="0"/>
+          <a:chOff x="0" y="0"/>
+          <a:chExt cx="0" cy="0"/>
+        </a:xfrm>
+      </p:grpSpPr>
+      <p:sp>
+        <p:nvSpPr>
+          <p:cNvPr id="3" name="TextBox 2">
+            <a:extLst>
+              <a:ext uri="{FF2B5EF4-FFF2-40B4-BE49-F238E27FC236}">
+                <a16:creationId xmlns:a16="http://schemas.microsoft.com/office/drawing/2014/main" id="{E93D9FF0-8AC5-44F1-25D4-91B9F6C018CB}"/>
+              </a:ext>
+            </a:extLst>
+          </p:cNvPr>
+          <p:cNvSpPr txBox="1"/>
+          <p:nvPr/>
+        </p:nvSpPr>
+        <p:spPr>
+          <a:xfrm>
+            <a:off x="217714" y="255046"/>
+            <a:ext cx="11756571" cy="355354"/>
+          </a:xfrm>
+          <a:prstGeom prst="rect">
+            <a:avLst/>
+          </a:prstGeom>
+          <a:noFill/>
+        </p:spPr>
+        <p:txBody>
+          <a:bodyPr wrap="square">
+            <a:spAutoFit/>
+          </a:bodyPr>
+          <a:lstStyle/>
+          <a:p>
+            <a:pPr>
+              <a:lnSpc>
+                <a:spcPct val="150000"/>
+              </a:lnSpc>
+              <a:buNone/>
+            </a:pPr>
+            <a:r>
+              <a:rPr kumimoji="0" lang="en-US" altLang="en-US" sz="1300" b="0" i="0" u="none" strike="noStrike" cap="none" normalizeH="0" baseline="0">
+                <a:ln>
+                  <a:noFill/>
+                </a:ln>
+                <a:solidFill>
+                  <a:schemeClr val="tx1"/>
+                </a:solidFill>
+                <a:effectLst/>
+                <a:latin typeface="Arial" panose="020B0604020202020204" pitchFamily="34" charset="0"/>
+              </a:rPr>
+              <a:t>.</a:t>
+            </a:r>
+          </a:p>
+        </p:txBody>
+      </p:sp>
+      <p:pic>
+        <p:nvPicPr>
+          <p:cNvPr id="4" name="Picture 3">
+            <a:extLst>
+              <a:ext uri="{FF2B5EF4-FFF2-40B4-BE49-F238E27FC236}">
+                <a16:creationId xmlns:a16="http://schemas.microsoft.com/office/drawing/2014/main" id="{E9DF0939-704A-FE48-55DE-C802B4B9F73A}"/>
+              </a:ext>
+            </a:extLst>
+          </p:cNvPr>
+          <p:cNvPicPr>
+            <a:picLocks noChangeAspect="1"/>
+          </p:cNvPicPr>
+          <p:nvPr/>
+        </p:nvPicPr>
+        <p:blipFill>
+          <a:blip r:embed="rId2"/>
+          <a:stretch>
+            <a:fillRect/>
+          </a:stretch>
+        </p:blipFill>
+        <p:spPr>
+          <a:xfrm>
+            <a:off x="-1" y="4278556"/>
+            <a:ext cx="12192000" cy="2579444"/>
+          </a:xfrm>
+          <a:prstGeom prst="rect">
+            <a:avLst/>
+          </a:prstGeom>
+          <a:ln w="38100" cap="sq">
+            <a:solidFill>
+              <a:srgbClr val="000000"/>
+            </a:solidFill>
+            <a:prstDash val="solid"/>
+            <a:miter lim="800000"/>
+          </a:ln>
+          <a:effectLst>
+            <a:outerShdw blurRad="50800" dist="38100" dir="2700000" algn="tl" rotWithShape="0">
+              <a:srgbClr val="000000">
+                <a:alpha val="43000"/>
+              </a:srgbClr>
+            </a:outerShdw>
+          </a:effectLst>
+        </p:spPr>
+      </p:pic>
+    </p:spTree>
+    <p:extLst>
+      <p:ext uri="{BB962C8B-B14F-4D97-AF65-F5344CB8AC3E}">
+        <p14:creationId xmlns:p14="http://schemas.microsoft.com/office/powerpoint/2010/main" val="3972593044"/>
+      </p:ext>
+    </p:extLst>
+  </p:cSld>
+  <p:clrMapOvr>
+    <a:masterClrMapping/>
+  </p:clrMapOvr>
+</p:sld>
+</file>
+
+<file path=ppt/slides/slide4.xml><?xml version="1.0" encoding="utf-8"?>
 <p:sld xmlns:a="http://schemas.openxmlformats.org/drawingml/2006/main" xmlns:r="http://schemas.openxmlformats.org/officeDocument/2006/relationships" xmlns:p="http://schemas.openxmlformats.org/presentationml/2006/main">
   <p:cSld>
     <p:spTree>
@@ -3455,7 +4169,7 @@
               <a:buNone/>
             </a:pPr>
             <a:r>
-              <a:rPr kumimoji="0" lang="en-US" altLang="en-US" sz="1300" b="0" i="0" u="none" strike="noStrike" cap="none" normalizeH="0" baseline="0">
+              <a:rPr kumimoji="0" lang="az-Latn-AZ" altLang="en-US" sz="1300" b="0" i="0" u="none" strike="noStrike" cap="none" normalizeH="0" baseline="0">
                 <a:ln>
                   <a:noFill/>
                 </a:ln>
@@ -3465,11 +4179,51 @@
                 <a:effectLst/>
                 <a:latin typeface="Arial" panose="020B0604020202020204" pitchFamily="34" charset="0"/>
               </a:rPr>
-              <a:t>.</a:t>
-            </a:r>
-          </a:p>
-        </p:txBody>
-      </p:sp>
+              <a:t>Ctrl + V etdikdən sonra isə müəyyən yerləri dəyişdiririk.</a:t>
+            </a:r>
+            <a:endParaRPr kumimoji="0" lang="en-US" altLang="en-US" sz="1300" b="0" i="0" u="none" strike="noStrike" cap="none" normalizeH="0" baseline="0">
+              <a:ln>
+                <a:noFill/>
+              </a:ln>
+              <a:solidFill>
+                <a:schemeClr val="tx1"/>
+              </a:solidFill>
+              <a:effectLst/>
+              <a:latin typeface="Arial" panose="020B0604020202020204" pitchFamily="34" charset="0"/>
+            </a:endParaRPr>
+          </a:p>
+        </p:txBody>
+      </p:sp>
+      <p:pic>
+        <p:nvPicPr>
+          <p:cNvPr id="4" name="Picture 3">
+            <a:extLst>
+              <a:ext uri="{FF2B5EF4-FFF2-40B4-BE49-F238E27FC236}">
+                <a16:creationId xmlns:a16="http://schemas.microsoft.com/office/drawing/2014/main" id="{2CFB8232-FAF4-764D-3218-ACF16AF5CFC3}"/>
+              </a:ext>
+            </a:extLst>
+          </p:cNvPr>
+          <p:cNvPicPr>
+            <a:picLocks noChangeAspect="1"/>
+          </p:cNvPicPr>
+          <p:nvPr/>
+        </p:nvPicPr>
+        <p:blipFill>
+          <a:blip r:embed="rId2"/>
+          <a:stretch>
+            <a:fillRect/>
+          </a:stretch>
+        </p:blipFill>
+        <p:spPr>
+          <a:xfrm>
+            <a:off x="-1" y="1621734"/>
+            <a:ext cx="12192000" cy="5236266"/>
+          </a:xfrm>
+          <a:prstGeom prst="rect">
+            <a:avLst/>
+          </a:prstGeom>
+        </p:spPr>
+      </p:pic>
     </p:spTree>
     <p:extLst>
       <p:ext uri="{BB962C8B-B14F-4D97-AF65-F5344CB8AC3E}">
@@ -3483,7 +4237,7 @@
 </p:sld>
 </file>
 
-<file path=ppt/slides/slide3.xml><?xml version="1.0" encoding="utf-8"?>
+<file path=ppt/slides/slide5.xml><?xml version="1.0" encoding="utf-8"?>
 <p:sld xmlns:a="http://schemas.openxmlformats.org/drawingml/2006/main" xmlns:r="http://schemas.openxmlformats.org/officeDocument/2006/relationships" xmlns:p="http://schemas.openxmlformats.org/presentationml/2006/main">
   <p:cSld>
     <p:spTree>
@@ -3491,7 +4245,7 @@
         <p:cNvPr id="1" name="">
           <a:extLst>
             <a:ext uri="{FF2B5EF4-FFF2-40B4-BE49-F238E27FC236}">
-              <a16:creationId xmlns:a16="http://schemas.microsoft.com/office/drawing/2014/main" id="{ECE25D7D-A080-F22B-7E8D-36EC827289A1}"/>
+              <a16:creationId xmlns:a16="http://schemas.microsoft.com/office/drawing/2014/main" id="{BCCBE459-0651-6ADE-784C-96C5FCFB7407}"/>
             </a:ext>
           </a:extLst>
         </p:cNvPr>
@@ -3511,7 +4265,7 @@
           <p:cNvPr id="3" name="TextBox 2">
             <a:extLst>
               <a:ext uri="{FF2B5EF4-FFF2-40B4-BE49-F238E27FC236}">
-                <a16:creationId xmlns:a16="http://schemas.microsoft.com/office/drawing/2014/main" id="{E33F16A3-A6E8-401E-847B-09570DC6E4CB}"/>
+                <a16:creationId xmlns:a16="http://schemas.microsoft.com/office/drawing/2014/main" id="{B4F160F3-D017-7BD1-3CED-A514937259DA}"/>
               </a:ext>
             </a:extLst>
           </p:cNvPr>
@@ -3556,10 +4310,519 @@
           </a:p>
         </p:txBody>
       </p:sp>
+      <p:pic>
+        <p:nvPicPr>
+          <p:cNvPr id="6" name="Picture 5">
+            <a:extLst>
+              <a:ext uri="{FF2B5EF4-FFF2-40B4-BE49-F238E27FC236}">
+                <a16:creationId xmlns:a16="http://schemas.microsoft.com/office/drawing/2014/main" id="{482CF01C-AEAC-5479-41E7-E3FA42B00322}"/>
+              </a:ext>
+            </a:extLst>
+          </p:cNvPr>
+          <p:cNvPicPr>
+            <a:picLocks noChangeAspect="1"/>
+          </p:cNvPicPr>
+          <p:nvPr/>
+        </p:nvPicPr>
+        <p:blipFill>
+          <a:blip r:embed="rId2"/>
+          <a:stretch>
+            <a:fillRect/>
+          </a:stretch>
+        </p:blipFill>
+        <p:spPr>
+          <a:xfrm>
+            <a:off x="2598602" y="0"/>
+            <a:ext cx="6994795" cy="6858000"/>
+          </a:xfrm>
+          <a:prstGeom prst="rect">
+            <a:avLst/>
+          </a:prstGeom>
+        </p:spPr>
+      </p:pic>
     </p:spTree>
     <p:extLst>
       <p:ext uri="{BB962C8B-B14F-4D97-AF65-F5344CB8AC3E}">
-        <p14:creationId xmlns:p14="http://schemas.microsoft.com/office/powerpoint/2010/main" val="3095838342"/>
+        <p14:creationId xmlns:p14="http://schemas.microsoft.com/office/powerpoint/2010/main" val="821201410"/>
+      </p:ext>
+    </p:extLst>
+  </p:cSld>
+  <p:clrMapOvr>
+    <a:masterClrMapping/>
+  </p:clrMapOvr>
+</p:sld>
+</file>
+
+<file path=ppt/slides/slide6.xml><?xml version="1.0" encoding="utf-8"?>
+<p:sld xmlns:a="http://schemas.openxmlformats.org/drawingml/2006/main" xmlns:r="http://schemas.openxmlformats.org/officeDocument/2006/relationships" xmlns:p="http://schemas.openxmlformats.org/presentationml/2006/main">
+  <p:cSld>
+    <p:spTree>
+      <p:nvGrpSpPr>
+        <p:cNvPr id="1" name="">
+          <a:extLst>
+            <a:ext uri="{FF2B5EF4-FFF2-40B4-BE49-F238E27FC236}">
+              <a16:creationId xmlns:a16="http://schemas.microsoft.com/office/drawing/2014/main" id="{A19295E5-9B65-CD5A-E1C1-5CC9C2E79F04}"/>
+            </a:ext>
+          </a:extLst>
+        </p:cNvPr>
+        <p:cNvGrpSpPr/>
+        <p:nvPr/>
+      </p:nvGrpSpPr>
+      <p:grpSpPr>
+        <a:xfrm>
+          <a:off x="0" y="0"/>
+          <a:ext cx="0" cy="0"/>
+          <a:chOff x="0" y="0"/>
+          <a:chExt cx="0" cy="0"/>
+        </a:xfrm>
+      </p:grpSpPr>
+      <p:sp>
+        <p:nvSpPr>
+          <p:cNvPr id="3" name="TextBox 2">
+            <a:extLst>
+              <a:ext uri="{FF2B5EF4-FFF2-40B4-BE49-F238E27FC236}">
+                <a16:creationId xmlns:a16="http://schemas.microsoft.com/office/drawing/2014/main" id="{23DFF268-EB5A-D008-D0C3-D9409B400674}"/>
+              </a:ext>
+            </a:extLst>
+          </p:cNvPr>
+          <p:cNvSpPr txBox="1"/>
+          <p:nvPr/>
+        </p:nvSpPr>
+        <p:spPr>
+          <a:xfrm>
+            <a:off x="217714" y="79503"/>
+            <a:ext cx="11756571" cy="355354"/>
+          </a:xfrm>
+          <a:prstGeom prst="rect">
+            <a:avLst/>
+          </a:prstGeom>
+          <a:noFill/>
+        </p:spPr>
+        <p:txBody>
+          <a:bodyPr wrap="square">
+            <a:spAutoFit/>
+          </a:bodyPr>
+          <a:lstStyle/>
+          <a:p>
+            <a:pPr>
+              <a:lnSpc>
+                <a:spcPct val="150000"/>
+              </a:lnSpc>
+              <a:buNone/>
+            </a:pPr>
+            <a:r>
+              <a:rPr lang="az-Latn-AZ" altLang="en-US" sz="1300">
+                <a:latin typeface="Arial" panose="020B0604020202020204" pitchFamily="34" charset="0"/>
+              </a:rPr>
+              <a:t>Template -dən bir İNPUT elementini kopyalayırıq.</a:t>
+            </a:r>
+            <a:endParaRPr kumimoji="0" lang="en-US" altLang="en-US" sz="1300" b="0" i="0" u="none" strike="noStrike" cap="none" normalizeH="0" baseline="0">
+              <a:ln>
+                <a:noFill/>
+              </a:ln>
+              <a:solidFill>
+                <a:schemeClr val="tx1"/>
+              </a:solidFill>
+              <a:effectLst/>
+              <a:latin typeface="Arial" panose="020B0604020202020204" pitchFamily="34" charset="0"/>
+            </a:endParaRPr>
+          </a:p>
+        </p:txBody>
+      </p:sp>
+      <p:pic>
+        <p:nvPicPr>
+          <p:cNvPr id="4" name="Picture 3">
+            <a:extLst>
+              <a:ext uri="{FF2B5EF4-FFF2-40B4-BE49-F238E27FC236}">
+                <a16:creationId xmlns:a16="http://schemas.microsoft.com/office/drawing/2014/main" id="{C099276B-7B13-26E0-9585-BF53EA85CA98}"/>
+              </a:ext>
+            </a:extLst>
+          </p:cNvPr>
+          <p:cNvPicPr>
+            <a:picLocks noChangeAspect="1"/>
+          </p:cNvPicPr>
+          <p:nvPr/>
+        </p:nvPicPr>
+        <p:blipFill>
+          <a:blip r:embed="rId2"/>
+          <a:stretch>
+            <a:fillRect/>
+          </a:stretch>
+        </p:blipFill>
+        <p:spPr>
+          <a:xfrm>
+            <a:off x="0" y="536457"/>
+            <a:ext cx="12192000" cy="6321543"/>
+          </a:xfrm>
+          <a:prstGeom prst="rect">
+            <a:avLst/>
+          </a:prstGeom>
+        </p:spPr>
+      </p:pic>
+    </p:spTree>
+    <p:extLst>
+      <p:ext uri="{BB962C8B-B14F-4D97-AF65-F5344CB8AC3E}">
+        <p14:creationId xmlns:p14="http://schemas.microsoft.com/office/powerpoint/2010/main" val="650548528"/>
+      </p:ext>
+    </p:extLst>
+  </p:cSld>
+  <p:clrMapOvr>
+    <a:masterClrMapping/>
+  </p:clrMapOvr>
+</p:sld>
+</file>
+
+<file path=ppt/slides/slide7.xml><?xml version="1.0" encoding="utf-8"?>
+<p:sld xmlns:a="http://schemas.openxmlformats.org/drawingml/2006/main" xmlns:r="http://schemas.openxmlformats.org/officeDocument/2006/relationships" xmlns:p="http://schemas.openxmlformats.org/presentationml/2006/main">
+  <p:cSld>
+    <p:spTree>
+      <p:nvGrpSpPr>
+        <p:cNvPr id="1" name="">
+          <a:extLst>
+            <a:ext uri="{FF2B5EF4-FFF2-40B4-BE49-F238E27FC236}">
+              <a16:creationId xmlns:a16="http://schemas.microsoft.com/office/drawing/2014/main" id="{25C8D537-3A29-2B15-7684-6DAA547A73D4}"/>
+            </a:ext>
+          </a:extLst>
+        </p:cNvPr>
+        <p:cNvGrpSpPr/>
+        <p:nvPr/>
+      </p:nvGrpSpPr>
+      <p:grpSpPr>
+        <a:xfrm>
+          <a:off x="0" y="0"/>
+          <a:ext cx="0" cy="0"/>
+          <a:chOff x="0" y="0"/>
+          <a:chExt cx="0" cy="0"/>
+        </a:xfrm>
+      </p:grpSpPr>
+      <p:sp>
+        <p:nvSpPr>
+          <p:cNvPr id="3" name="TextBox 2">
+            <a:extLst>
+              <a:ext uri="{FF2B5EF4-FFF2-40B4-BE49-F238E27FC236}">
+                <a16:creationId xmlns:a16="http://schemas.microsoft.com/office/drawing/2014/main" id="{6E9F0C13-336D-1DCA-D0EB-01C50E5B2889}"/>
+              </a:ext>
+            </a:extLst>
+          </p:cNvPr>
+          <p:cNvSpPr txBox="1"/>
+          <p:nvPr/>
+        </p:nvSpPr>
+        <p:spPr>
+          <a:xfrm>
+            <a:off x="217714" y="255046"/>
+            <a:ext cx="11756571" cy="355354"/>
+          </a:xfrm>
+          <a:prstGeom prst="rect">
+            <a:avLst/>
+          </a:prstGeom>
+          <a:noFill/>
+        </p:spPr>
+        <p:txBody>
+          <a:bodyPr wrap="square">
+            <a:spAutoFit/>
+          </a:bodyPr>
+          <a:lstStyle/>
+          <a:p>
+            <a:pPr>
+              <a:lnSpc>
+                <a:spcPct val="150000"/>
+              </a:lnSpc>
+              <a:buNone/>
+            </a:pPr>
+            <a:r>
+              <a:rPr lang="az-Latn-AZ" altLang="en-US" sz="1300" b="1">
+                <a:latin typeface="Arial" panose="020B0604020202020204" pitchFamily="34" charset="0"/>
+              </a:rPr>
+              <a:t>FORM</a:t>
+            </a:r>
+            <a:r>
+              <a:rPr lang="az-Latn-AZ" altLang="en-US" sz="1300">
+                <a:latin typeface="Arial" panose="020B0604020202020204" pitchFamily="34" charset="0"/>
+              </a:rPr>
+              <a:t> elementi yaradaraq onun içinə yerləşdiririk.</a:t>
+            </a:r>
+            <a:endParaRPr kumimoji="0" lang="en-US" altLang="en-US" sz="1300" b="0" i="0" u="none" strike="noStrike" cap="none" normalizeH="0" baseline="0">
+              <a:ln>
+                <a:noFill/>
+              </a:ln>
+              <a:solidFill>
+                <a:schemeClr val="tx1"/>
+              </a:solidFill>
+              <a:effectLst/>
+              <a:latin typeface="Arial" panose="020B0604020202020204" pitchFamily="34" charset="0"/>
+            </a:endParaRPr>
+          </a:p>
+        </p:txBody>
+      </p:sp>
+      <p:pic>
+        <p:nvPicPr>
+          <p:cNvPr id="4" name="Picture 3">
+            <a:extLst>
+              <a:ext uri="{FF2B5EF4-FFF2-40B4-BE49-F238E27FC236}">
+                <a16:creationId xmlns:a16="http://schemas.microsoft.com/office/drawing/2014/main" id="{B1A384D4-EAD8-1A5E-41D1-48A2A01E3A6D}"/>
+              </a:ext>
+            </a:extLst>
+          </p:cNvPr>
+          <p:cNvPicPr>
+            <a:picLocks noChangeAspect="1"/>
+          </p:cNvPicPr>
+          <p:nvPr/>
+        </p:nvPicPr>
+        <p:blipFill>
+          <a:blip r:embed="rId2"/>
+          <a:stretch>
+            <a:fillRect/>
+          </a:stretch>
+        </p:blipFill>
+        <p:spPr>
+          <a:xfrm>
+            <a:off x="6095999" y="0"/>
+            <a:ext cx="6094071" cy="6858000"/>
+          </a:xfrm>
+          <a:prstGeom prst="rect">
+            <a:avLst/>
+          </a:prstGeom>
+        </p:spPr>
+      </p:pic>
+    </p:spTree>
+    <p:extLst>
+      <p:ext uri="{BB962C8B-B14F-4D97-AF65-F5344CB8AC3E}">
+        <p14:creationId xmlns:p14="http://schemas.microsoft.com/office/powerpoint/2010/main" val="2787526344"/>
+      </p:ext>
+    </p:extLst>
+  </p:cSld>
+  <p:clrMapOvr>
+    <a:masterClrMapping/>
+  </p:clrMapOvr>
+</p:sld>
+</file>
+
+<file path=ppt/slides/slide8.xml><?xml version="1.0" encoding="utf-8"?>
+<p:sld xmlns:a="http://schemas.openxmlformats.org/drawingml/2006/main" xmlns:r="http://schemas.openxmlformats.org/officeDocument/2006/relationships" xmlns:p="http://schemas.openxmlformats.org/presentationml/2006/main">
+  <p:cSld>
+    <p:spTree>
+      <p:nvGrpSpPr>
+        <p:cNvPr id="1" name="">
+          <a:extLst>
+            <a:ext uri="{FF2B5EF4-FFF2-40B4-BE49-F238E27FC236}">
+              <a16:creationId xmlns:a16="http://schemas.microsoft.com/office/drawing/2014/main" id="{60AEBEE2-DA76-E894-674D-1C06654AD0C6}"/>
+            </a:ext>
+          </a:extLst>
+        </p:cNvPr>
+        <p:cNvGrpSpPr/>
+        <p:nvPr/>
+      </p:nvGrpSpPr>
+      <p:grpSpPr>
+        <a:xfrm>
+          <a:off x="0" y="0"/>
+          <a:ext cx="0" cy="0"/>
+          <a:chOff x="0" y="0"/>
+          <a:chExt cx="0" cy="0"/>
+        </a:xfrm>
+      </p:grpSpPr>
+      <p:sp>
+        <p:nvSpPr>
+          <p:cNvPr id="3" name="TextBox 2">
+            <a:extLst>
+              <a:ext uri="{FF2B5EF4-FFF2-40B4-BE49-F238E27FC236}">
+                <a16:creationId xmlns:a16="http://schemas.microsoft.com/office/drawing/2014/main" id="{40B3C2E5-EA7A-E69B-1F43-ABFF59B1C0FE}"/>
+              </a:ext>
+            </a:extLst>
+          </p:cNvPr>
+          <p:cNvSpPr txBox="1"/>
+          <p:nvPr/>
+        </p:nvSpPr>
+        <p:spPr>
+          <a:xfrm>
+            <a:off x="217714" y="83128"/>
+            <a:ext cx="11756571" cy="355354"/>
+          </a:xfrm>
+          <a:prstGeom prst="rect">
+            <a:avLst/>
+          </a:prstGeom>
+          <a:noFill/>
+        </p:spPr>
+        <p:txBody>
+          <a:bodyPr wrap="square">
+            <a:spAutoFit/>
+          </a:bodyPr>
+          <a:lstStyle/>
+          <a:p>
+            <a:pPr>
+              <a:lnSpc>
+                <a:spcPct val="150000"/>
+              </a:lnSpc>
+              <a:buNone/>
+            </a:pPr>
+            <a:r>
+              <a:rPr lang="az-Latn-AZ" altLang="en-US" sz="1300">
+                <a:latin typeface="Arial" panose="020B0604020202020204" pitchFamily="34" charset="0"/>
+              </a:rPr>
+              <a:t>COPY</a:t>
+            </a:r>
+            <a:endParaRPr kumimoji="0" lang="en-US" altLang="en-US" sz="1300" b="0" i="0" u="none" strike="noStrike" cap="none" normalizeH="0" baseline="0">
+              <a:ln>
+                <a:noFill/>
+              </a:ln>
+              <a:solidFill>
+                <a:schemeClr val="tx1"/>
+              </a:solidFill>
+              <a:effectLst/>
+              <a:latin typeface="Arial" panose="020B0604020202020204" pitchFamily="34" charset="0"/>
+            </a:endParaRPr>
+          </a:p>
+        </p:txBody>
+      </p:sp>
+      <p:pic>
+        <p:nvPicPr>
+          <p:cNvPr id="4" name="Picture 3">
+            <a:extLst>
+              <a:ext uri="{FF2B5EF4-FFF2-40B4-BE49-F238E27FC236}">
+                <a16:creationId xmlns:a16="http://schemas.microsoft.com/office/drawing/2014/main" id="{695E9333-D9DE-3B4C-464E-6BF1DA947595}"/>
+              </a:ext>
+            </a:extLst>
+          </p:cNvPr>
+          <p:cNvPicPr>
+            <a:picLocks noChangeAspect="1"/>
+          </p:cNvPicPr>
+          <p:nvPr/>
+        </p:nvPicPr>
+        <p:blipFill>
+          <a:blip r:embed="rId2"/>
+          <a:stretch>
+            <a:fillRect/>
+          </a:stretch>
+        </p:blipFill>
+        <p:spPr>
+          <a:xfrm>
+            <a:off x="0" y="561871"/>
+            <a:ext cx="12192000" cy="6296129"/>
+          </a:xfrm>
+          <a:prstGeom prst="rect">
+            <a:avLst/>
+          </a:prstGeom>
+        </p:spPr>
+      </p:pic>
+    </p:spTree>
+    <p:extLst>
+      <p:ext uri="{BB962C8B-B14F-4D97-AF65-F5344CB8AC3E}">
+        <p14:creationId xmlns:p14="http://schemas.microsoft.com/office/powerpoint/2010/main" val="3813316368"/>
+      </p:ext>
+    </p:extLst>
+  </p:cSld>
+  <p:clrMapOvr>
+    <a:masterClrMapping/>
+  </p:clrMapOvr>
+</p:sld>
+</file>
+
+<file path=ppt/slides/slide9.xml><?xml version="1.0" encoding="utf-8"?>
+<p:sld xmlns:a="http://schemas.openxmlformats.org/drawingml/2006/main" xmlns:r="http://schemas.openxmlformats.org/officeDocument/2006/relationships" xmlns:p="http://schemas.openxmlformats.org/presentationml/2006/main">
+  <p:cSld>
+    <p:spTree>
+      <p:nvGrpSpPr>
+        <p:cNvPr id="1" name="">
+          <a:extLst>
+            <a:ext uri="{FF2B5EF4-FFF2-40B4-BE49-F238E27FC236}">
+              <a16:creationId xmlns:a16="http://schemas.microsoft.com/office/drawing/2014/main" id="{F7BB8391-FA08-B1E2-E516-5831A7209C03}"/>
+            </a:ext>
+          </a:extLst>
+        </p:cNvPr>
+        <p:cNvGrpSpPr/>
+        <p:nvPr/>
+      </p:nvGrpSpPr>
+      <p:grpSpPr>
+        <a:xfrm>
+          <a:off x="0" y="0"/>
+          <a:ext cx="0" cy="0"/>
+          <a:chOff x="0" y="0"/>
+          <a:chExt cx="0" cy="0"/>
+        </a:xfrm>
+      </p:grpSpPr>
+      <p:sp>
+        <p:nvSpPr>
+          <p:cNvPr id="3" name="TextBox 2">
+            <a:extLst>
+              <a:ext uri="{FF2B5EF4-FFF2-40B4-BE49-F238E27FC236}">
+                <a16:creationId xmlns:a16="http://schemas.microsoft.com/office/drawing/2014/main" id="{A2FC0B23-C346-1A5A-F8D4-F62DFFBF29D2}"/>
+              </a:ext>
+            </a:extLst>
+          </p:cNvPr>
+          <p:cNvSpPr txBox="1"/>
+          <p:nvPr/>
+        </p:nvSpPr>
+        <p:spPr>
+          <a:xfrm>
+            <a:off x="217714" y="255046"/>
+            <a:ext cx="11756571" cy="355354"/>
+          </a:xfrm>
+          <a:prstGeom prst="rect">
+            <a:avLst/>
+          </a:prstGeom>
+          <a:noFill/>
+        </p:spPr>
+        <p:txBody>
+          <a:bodyPr wrap="square">
+            <a:spAutoFit/>
+          </a:bodyPr>
+          <a:lstStyle/>
+          <a:p>
+            <a:pPr>
+              <a:lnSpc>
+                <a:spcPct val="150000"/>
+              </a:lnSpc>
+              <a:buNone/>
+            </a:pPr>
+            <a:r>
+              <a:rPr kumimoji="0" lang="en-US" altLang="en-US" sz="1300" b="0" i="0" u="none" strike="noStrike" cap="none" normalizeH="0" baseline="0">
+                <a:ln>
+                  <a:noFill/>
+                </a:ln>
+                <a:solidFill>
+                  <a:schemeClr val="tx1"/>
+                </a:solidFill>
+                <a:effectLst/>
+                <a:latin typeface="Arial" panose="020B0604020202020204" pitchFamily="34" charset="0"/>
+              </a:rPr>
+              <a:t>.</a:t>
+            </a:r>
+          </a:p>
+        </p:txBody>
+      </p:sp>
+      <p:pic>
+        <p:nvPicPr>
+          <p:cNvPr id="4" name="Picture 3">
+            <a:extLst>
+              <a:ext uri="{FF2B5EF4-FFF2-40B4-BE49-F238E27FC236}">
+                <a16:creationId xmlns:a16="http://schemas.microsoft.com/office/drawing/2014/main" id="{364F70D6-E60D-35A0-DAB4-FF96625999EE}"/>
+              </a:ext>
+            </a:extLst>
+          </p:cNvPr>
+          <p:cNvPicPr>
+            <a:picLocks noChangeAspect="1"/>
+          </p:cNvPicPr>
+          <p:nvPr/>
+        </p:nvPicPr>
+        <p:blipFill>
+          <a:blip r:embed="rId2"/>
+          <a:stretch>
+            <a:fillRect/>
+          </a:stretch>
+        </p:blipFill>
+        <p:spPr>
+          <a:xfrm>
+            <a:off x="3420967" y="0"/>
+            <a:ext cx="5350066" cy="6858000"/>
+          </a:xfrm>
+          <a:prstGeom prst="rect">
+            <a:avLst/>
+          </a:prstGeom>
+        </p:spPr>
+      </p:pic>
+    </p:spTree>
+    <p:extLst>
+      <p:ext uri="{BB962C8B-B14F-4D97-AF65-F5344CB8AC3E}">
+        <p14:creationId xmlns:p14="http://schemas.microsoft.com/office/powerpoint/2010/main" val="450236983"/>
       </p:ext>
     </p:extLst>
   </p:cSld>

</xml_diff>